<commit_message>
render: W25 mon (auto-published from production-dispatcher)
</commit_message>
<xml_diff>
--- a/W25-940c86/mon/slides/01-cover-plate.pptx
+++ b/W25-940c86/mon/slides/01-cover-plate.pptx
@@ -3276,7 +3276,16 @@
                 </a:solidFill>
                 <a:latin typeface="Playfair Display"/>
               </a:rPr>
-              <a:t>The data behind that</a:t>
+              <a:t>Still waiting for a </a:t>
+            </a:r>
+            <a:r>
+              <a:rPr sz="3800" b="1" i="1">
+                <a:solidFill>
+                  <a:srgbClr val="540918"/>
+                </a:solidFill>
+                <a:latin typeface="Playfair Display"/>
+              </a:rPr>
+              <a:t>lower rate?</a:t>
             </a:r>
           </a:p>
         </p:txBody>

</xml_diff>